<commit_message>
Split semester slide into three; rebuild report + speaker notes
Deck: replaces the single stacked semester slide with three separate
left-panel slides (Fall, Spring, Summer), each with its own headline,
subtext, and the corresponding chart on the right. Total deck length
goes from 9 to 11 slides; subsequent chart-slide page numbers shift
accordingly.

Word report: the "Gross vs Net Tuition" section now contains three
subsections (2a Fall, 2b Spring, 2c Summer), each with the relevant
chart inline and a per-semester narrative.

Speaker notes: the single slide-4 entry becomes three slide-by-slide
sections (4 Fall / 5 Spring / 6 Summer), each with a "What to say"
bullet list and a gold TIP box. All subsequent slide headings
renumbered (5→7, 6→8, 7→9, 8→10, 9→11).

Co-Authored-By: Claude Opus 4.7 (1M context) <noreply@anthropic.com>
</commit_message>
<xml_diff>
--- a/deliverables/emory_grad_pricing_v2.pptx
+++ b/deliverables/emory_grad_pricing_v2.pptx
@@ -14,6 +14,8 @@
     <p:sldId id="262" r:id="rId13"/>
     <p:sldId id="263" r:id="rId14"/>
     <p:sldId id="264" r:id="rId15"/>
+    <p:sldId id="265" r:id="rId16"/>
+    <p:sldId id="266" r:id="rId17"/>
   </p:sldIdLst>
   <p:sldSz cx="12191695" cy="6858000" type="screen4x3"/>
   <p:notesSz cx="6858000" cy="9144000"/>
@@ -3295,6 +3297,644 @@
 </p:sld>
 </file>
 
+<file path=ppt/slides/slide10.xml><?xml version="1.0" encoding="utf-8"?>
+<p:sld xmlns:a="http://schemas.openxmlformats.org/drawingml/2006/main" xmlns:p="http://schemas.openxmlformats.org/presentationml/2006/main" xmlns:r="http://schemas.openxmlformats.org/officeDocument/2006/relationships">
+  <p:cSld>
+    <p:spTree>
+      <p:nvGrpSpPr>
+        <p:cNvPr id="1" name=""/>
+        <p:cNvGrpSpPr/>
+        <p:nvPr/>
+      </p:nvGrpSpPr>
+      <p:grpSpPr/>
+      <p:sp>
+        <p:nvSpPr>
+          <p:cNvPr id="2" name="Rectangle 1"/>
+          <p:cNvSpPr/>
+          <p:nvPr/>
+        </p:nvSpPr>
+        <p:spPr>
+          <a:xfrm>
+            <a:off x="0" y="0"/>
+            <a:ext cx="12191695" cy="1188720"/>
+          </a:xfrm>
+          <a:prstGeom prst="rect">
+            <a:avLst/>
+          </a:prstGeom>
+          <a:solidFill>
+            <a:srgbClr val="012169"/>
+          </a:solidFill>
+          <a:ln>
+            <a:noFill/>
+          </a:ln>
+        </p:spPr>
+        <p:style>
+          <a:lnRef idx="1">
+            <a:schemeClr val="accent1"/>
+          </a:lnRef>
+          <a:fillRef idx="3">
+            <a:schemeClr val="accent1"/>
+          </a:fillRef>
+          <a:effectRef idx="2">
+            <a:schemeClr val="accent1"/>
+          </a:effectRef>
+          <a:fontRef idx="minor">
+            <a:schemeClr val="lt1"/>
+          </a:fontRef>
+        </p:style>
+        <p:txBody>
+          <a:bodyPr rtlCol="0" anchor="ctr"/>
+          <a:lstStyle/>
+          <a:p>
+            <a:pPr algn="ctr"/>
+          </a:p>
+        </p:txBody>
+      </p:sp>
+      <p:sp>
+        <p:nvSpPr>
+          <p:cNvPr id="3" name="TextBox 2"/>
+          <p:cNvSpPr txBox="1"/>
+          <p:nvPr/>
+        </p:nvSpPr>
+        <p:spPr>
+          <a:xfrm>
+            <a:off x="457200" y="228600"/>
+            <a:ext cx="11277295" cy="777240"/>
+          </a:xfrm>
+          <a:prstGeom prst="rect">
+            <a:avLst/>
+          </a:prstGeom>
+          <a:noFill/>
+        </p:spPr>
+        <p:txBody>
+          <a:bodyPr wrap="square">
+            <a:spAutoFit/>
+          </a:bodyPr>
+          <a:lstStyle/>
+          <a:p>
+            <a:pPr algn="l"/>
+            <a:r>
+              <a:rPr sz="2000" b="1">
+                <a:solidFill>
+                  <a:srgbClr val="FFFFFF"/>
+                </a:solidFill>
+                <a:latin typeface="Calibri"/>
+              </a:rPr>
+              <a:t>Emory's annualized tuition ($47–51k) undercuts Columbia/NYU by $20–40k and sits above Georgia Tech's in-state rates — mid-market positioning</a:t>
+            </a:r>
+          </a:p>
+        </p:txBody>
+      </p:sp>
+      <p:sp>
+        <p:nvSpPr>
+          <p:cNvPr id="4" name="Rectangle 3"/>
+          <p:cNvSpPr/>
+          <p:nvPr/>
+        </p:nvSpPr>
+        <p:spPr>
+          <a:xfrm>
+            <a:off x="0" y="1188720"/>
+            <a:ext cx="12191695" cy="54864"/>
+          </a:xfrm>
+          <a:prstGeom prst="rect">
+            <a:avLst/>
+          </a:prstGeom>
+          <a:solidFill>
+            <a:srgbClr val="F2A900"/>
+          </a:solidFill>
+          <a:ln>
+            <a:noFill/>
+          </a:ln>
+        </p:spPr>
+        <p:style>
+          <a:lnRef idx="1">
+            <a:schemeClr val="accent1"/>
+          </a:lnRef>
+          <a:fillRef idx="3">
+            <a:schemeClr val="accent1"/>
+          </a:fillRef>
+          <a:effectRef idx="2">
+            <a:schemeClr val="accent1"/>
+          </a:effectRef>
+          <a:fontRef idx="minor">
+            <a:schemeClr val="lt1"/>
+          </a:fontRef>
+        </p:style>
+        <p:txBody>
+          <a:bodyPr rtlCol="0" anchor="ctr"/>
+          <a:lstStyle/>
+          <a:p>
+            <a:pPr algn="ctr"/>
+          </a:p>
+        </p:txBody>
+      </p:sp>
+      <p:pic>
+        <p:nvPicPr>
+          <p:cNvPr id="5" name="Picture 4" descr="06_peer_benchmark_emory_vs_peers.png"/>
+          <p:cNvPicPr>
+            <a:picLocks noChangeAspect="1"/>
+          </p:cNvPicPr>
+          <p:nvPr/>
+        </p:nvPicPr>
+        <p:blipFill>
+          <a:blip r:embed="rId2"/>
+          <a:stretch>
+            <a:fillRect/>
+          </a:stretch>
+        </p:blipFill>
+        <p:spPr>
+          <a:xfrm>
+            <a:off x="457200" y="1463040"/>
+            <a:ext cx="11277295" cy="5029200"/>
+          </a:xfrm>
+          <a:prstGeom prst="rect">
+            <a:avLst/>
+          </a:prstGeom>
+        </p:spPr>
+      </p:pic>
+      <p:sp>
+        <p:nvSpPr>
+          <p:cNvPr id="6" name="TextBox 5"/>
+          <p:cNvSpPr txBox="1"/>
+          <p:nvPr/>
+        </p:nvSpPr>
+        <p:spPr>
+          <a:xfrm>
+            <a:off x="11460175" y="6537960"/>
+            <a:ext cx="548640" cy="274320"/>
+          </a:xfrm>
+          <a:prstGeom prst="rect">
+            <a:avLst/>
+          </a:prstGeom>
+          <a:noFill/>
+        </p:spPr>
+        <p:txBody>
+          <a:bodyPr wrap="square">
+            <a:spAutoFit/>
+          </a:bodyPr>
+          <a:lstStyle/>
+          <a:p>
+            <a:pPr algn="r"/>
+            <a:r>
+              <a:rPr sz="1100" b="0">
+                <a:solidFill>
+                  <a:srgbClr val="012169"/>
+                </a:solidFill>
+                <a:latin typeface="Calibri"/>
+              </a:rPr>
+              <a:t>10</a:t>
+            </a:r>
+          </a:p>
+        </p:txBody>
+      </p:sp>
+    </p:spTree>
+  </p:cSld>
+  <p:clrMapOvr>
+    <a:masterClrMapping/>
+  </p:clrMapOvr>
+</p:sld>
+</file>
+
+<file path=ppt/slides/slide11.xml><?xml version="1.0" encoding="utf-8"?>
+<p:sld xmlns:a="http://schemas.openxmlformats.org/drawingml/2006/main" xmlns:p="http://schemas.openxmlformats.org/presentationml/2006/main" xmlns:r="http://schemas.openxmlformats.org/officeDocument/2006/relationships">
+  <p:cSld>
+    <p:spTree>
+      <p:nvGrpSpPr>
+        <p:cNvPr id="1" name=""/>
+        <p:cNvGrpSpPr/>
+        <p:nvPr/>
+      </p:nvGrpSpPr>
+      <p:grpSpPr/>
+      <p:sp>
+        <p:nvSpPr>
+          <p:cNvPr id="2" name="Rectangle 1"/>
+          <p:cNvSpPr/>
+          <p:nvPr/>
+        </p:nvSpPr>
+        <p:spPr>
+          <a:xfrm>
+            <a:off x="0" y="0"/>
+            <a:ext cx="12191695" cy="914400"/>
+          </a:xfrm>
+          <a:prstGeom prst="rect">
+            <a:avLst/>
+          </a:prstGeom>
+          <a:solidFill>
+            <a:srgbClr val="012169"/>
+          </a:solidFill>
+          <a:ln>
+            <a:noFill/>
+          </a:ln>
+        </p:spPr>
+        <p:style>
+          <a:lnRef idx="1">
+            <a:schemeClr val="accent1"/>
+          </a:lnRef>
+          <a:fillRef idx="3">
+            <a:schemeClr val="accent1"/>
+          </a:fillRef>
+          <a:effectRef idx="2">
+            <a:schemeClr val="accent1"/>
+          </a:effectRef>
+          <a:fontRef idx="minor">
+            <a:schemeClr val="lt1"/>
+          </a:fontRef>
+        </p:style>
+        <p:txBody>
+          <a:bodyPr rtlCol="0" anchor="ctr"/>
+          <a:lstStyle/>
+          <a:p>
+            <a:pPr algn="ctr"/>
+          </a:p>
+        </p:txBody>
+      </p:sp>
+      <p:sp>
+        <p:nvSpPr>
+          <p:cNvPr id="3" name="TextBox 2"/>
+          <p:cNvSpPr txBox="1"/>
+          <p:nvPr/>
+        </p:nvSpPr>
+        <p:spPr>
+          <a:xfrm>
+            <a:off x="457200" y="182880"/>
+            <a:ext cx="11277295" cy="640080"/>
+          </a:xfrm>
+          <a:prstGeom prst="rect">
+            <a:avLst/>
+          </a:prstGeom>
+          <a:noFill/>
+        </p:spPr>
+        <p:txBody>
+          <a:bodyPr wrap="square">
+            <a:spAutoFit/>
+          </a:bodyPr>
+          <a:lstStyle/>
+          <a:p>
+            <a:pPr algn="l"/>
+            <a:r>
+              <a:rPr sz="2600" b="1">
+                <a:solidFill>
+                  <a:srgbClr val="FFFFFF"/>
+                </a:solidFill>
+                <a:latin typeface="Calibri"/>
+              </a:rPr>
+              <a:t>Data Notes &amp; Methodology</a:t>
+            </a:r>
+          </a:p>
+        </p:txBody>
+      </p:sp>
+      <p:sp>
+        <p:nvSpPr>
+          <p:cNvPr id="4" name="Rectangle 3"/>
+          <p:cNvSpPr/>
+          <p:nvPr/>
+        </p:nvSpPr>
+        <p:spPr>
+          <a:xfrm>
+            <a:off x="0" y="914400"/>
+            <a:ext cx="12191695" cy="73152"/>
+          </a:xfrm>
+          <a:prstGeom prst="rect">
+            <a:avLst/>
+          </a:prstGeom>
+          <a:solidFill>
+            <a:srgbClr val="F2A900"/>
+          </a:solidFill>
+          <a:ln>
+            <a:noFill/>
+          </a:ln>
+        </p:spPr>
+        <p:style>
+          <a:lnRef idx="1">
+            <a:schemeClr val="accent1"/>
+          </a:lnRef>
+          <a:fillRef idx="3">
+            <a:schemeClr val="accent1"/>
+          </a:fillRef>
+          <a:effectRef idx="2">
+            <a:schemeClr val="accent1"/>
+          </a:effectRef>
+          <a:fontRef idx="minor">
+            <a:schemeClr val="lt1"/>
+          </a:fontRef>
+        </p:style>
+        <p:txBody>
+          <a:bodyPr rtlCol="0" anchor="ctr"/>
+          <a:lstStyle/>
+          <a:p>
+            <a:pPr algn="ctr"/>
+          </a:p>
+        </p:txBody>
+      </p:sp>
+      <p:sp>
+        <p:nvSpPr>
+          <p:cNvPr id="5" name="TextBox 4"/>
+          <p:cNvSpPr txBox="1"/>
+          <p:nvPr/>
+        </p:nvSpPr>
+        <p:spPr>
+          <a:xfrm>
+            <a:off x="457200" y="1280160"/>
+            <a:ext cx="11277295" cy="822960"/>
+          </a:xfrm>
+          <a:prstGeom prst="rect">
+            <a:avLst/>
+          </a:prstGeom>
+          <a:noFill/>
+        </p:spPr>
+        <p:txBody>
+          <a:bodyPr wrap="square">
+            <a:spAutoFit/>
+          </a:bodyPr>
+          <a:lstStyle/>
+          <a:p>
+            <a:r>
+              <a:rPr sz="1400" b="1">
+                <a:solidFill>
+                  <a:srgbClr val="F2A900"/>
+                </a:solidFill>
+                <a:latin typeface="Calibri"/>
+              </a:rPr>
+              <a:t>• </a:t>
+            </a:r>
+            <a:r>
+              <a:rPr sz="1300">
+                <a:solidFill>
+                  <a:srgbClr val="222222"/>
+                </a:solidFill>
+                <a:latin typeface="Calibri"/>
+              </a:rPr>
+              <a:t>Source data: institutional Excel exports of gross tuition billed and LGS scholarship awards; 8-year panel spanning AY 2019 through AY 2026.</a:t>
+            </a:r>
+          </a:p>
+        </p:txBody>
+      </p:sp>
+      <p:sp>
+        <p:nvSpPr>
+          <p:cNvPr id="6" name="TextBox 5"/>
+          <p:cNvSpPr txBox="1"/>
+          <p:nvPr/>
+        </p:nvSpPr>
+        <p:spPr>
+          <a:xfrm>
+            <a:off x="457200" y="2057400"/>
+            <a:ext cx="11277295" cy="822960"/>
+          </a:xfrm>
+          <a:prstGeom prst="rect">
+            <a:avLst/>
+          </a:prstGeom>
+          <a:noFill/>
+        </p:spPr>
+        <p:txBody>
+          <a:bodyPr wrap="square">
+            <a:spAutoFit/>
+          </a:bodyPr>
+          <a:lstStyle/>
+          <a:p>
+            <a:r>
+              <a:rPr sz="1400" b="1">
+                <a:solidFill>
+                  <a:srgbClr val="F2A900"/>
+                </a:solidFill>
+                <a:latin typeface="Calibri"/>
+              </a:rPr>
+              <a:t>• </a:t>
+            </a:r>
+            <a:r>
+              <a:rPr sz="1300">
+                <a:solidFill>
+                  <a:srgbClr val="222222"/>
+                </a:solidFill>
+                <a:latin typeface="Calibri"/>
+              </a:rPr>
+              <a:t>Net tuition is clipped at zero. In rare cases a kept scholarship exceeds billed tuition for a partial-term student; we report that student as paying $0 rather than a negative amount.</a:t>
+            </a:r>
+          </a:p>
+        </p:txBody>
+      </p:sp>
+      <p:sp>
+        <p:nvSpPr>
+          <p:cNvPr id="7" name="TextBox 6"/>
+          <p:cNvSpPr txBox="1"/>
+          <p:nvPr/>
+        </p:nvSpPr>
+        <p:spPr>
+          <a:xfrm>
+            <a:off x="457200" y="2834640"/>
+            <a:ext cx="11277295" cy="822960"/>
+          </a:xfrm>
+          <a:prstGeom prst="rect">
+            <a:avLst/>
+          </a:prstGeom>
+          <a:noFill/>
+        </p:spPr>
+        <p:txBody>
+          <a:bodyPr wrap="square">
+            <a:spAutoFit/>
+          </a:bodyPr>
+          <a:lstStyle/>
+          <a:p>
+            <a:r>
+              <a:rPr sz="1400" b="1">
+                <a:solidFill>
+                  <a:srgbClr val="F2A900"/>
+                </a:solidFill>
+                <a:latin typeface="Calibri"/>
+              </a:rPr>
+              <a:t>• </a:t>
+            </a:r>
+            <a:r>
+              <a:rPr sz="1300">
+                <a:solidFill>
+                  <a:srgbClr val="222222"/>
+                </a:solidFill>
+                <a:latin typeface="Calibri"/>
+              </a:rPr>
+              <a:t>Scholarship filter retains descriptions containing 'lgs' and drops external/federal awards (Pell, GRFP, Yellow Ribbon, Americorps, etc.) plus generic LGS 'special' awards, so discount rates reflect institutional aid only.</a:t>
+            </a:r>
+          </a:p>
+        </p:txBody>
+      </p:sp>
+      <p:sp>
+        <p:nvSpPr>
+          <p:cNvPr id="8" name="TextBox 7"/>
+          <p:cNvSpPr txBox="1"/>
+          <p:nvPr/>
+        </p:nvSpPr>
+        <p:spPr>
+          <a:xfrm>
+            <a:off x="457200" y="3611880"/>
+            <a:ext cx="11277295" cy="822960"/>
+          </a:xfrm>
+          <a:prstGeom prst="rect">
+            <a:avLst/>
+          </a:prstGeom>
+          <a:noFill/>
+        </p:spPr>
+        <p:txBody>
+          <a:bodyPr wrap="square">
+            <a:spAutoFit/>
+          </a:bodyPr>
+          <a:lstStyle/>
+          <a:p>
+            <a:r>
+              <a:rPr sz="1400" b="1">
+                <a:solidFill>
+                  <a:srgbClr val="F2A900"/>
+                </a:solidFill>
+                <a:latin typeface="Calibri"/>
+              </a:rPr>
+              <a:t>• </a:t>
+            </a:r>
+            <a:r>
+              <a:rPr sz="1300">
+                <a:solidFill>
+                  <a:srgbClr val="222222"/>
+                </a:solidFill>
+                <a:latin typeface="Calibri"/>
+              </a:rPr>
+              <a:t>Small-n programs are merged: ECONMS + ECON4P1MS → Economics; DATASCIMS + QTMMS → Data Science; DEVPRACMDP + HUMANRTCRT → MDP.</a:t>
+            </a:r>
+          </a:p>
+        </p:txBody>
+      </p:sp>
+      <p:sp>
+        <p:nvSpPr>
+          <p:cNvPr id="9" name="TextBox 8"/>
+          <p:cNvSpPr txBox="1"/>
+          <p:nvPr/>
+        </p:nvSpPr>
+        <p:spPr>
+          <a:xfrm>
+            <a:off x="457200" y="4389120"/>
+            <a:ext cx="11277295" cy="822960"/>
+          </a:xfrm>
+          <a:prstGeom prst="rect">
+            <a:avLst/>
+          </a:prstGeom>
+          <a:noFill/>
+        </p:spPr>
+        <p:txBody>
+          <a:bodyPr wrap="square">
+            <a:spAutoFit/>
+          </a:bodyPr>
+          <a:lstStyle/>
+          <a:p>
+            <a:r>
+              <a:rPr sz="1400" b="1">
+                <a:solidFill>
+                  <a:srgbClr val="F2A900"/>
+                </a:solidFill>
+                <a:latin typeface="Calibri"/>
+              </a:rPr>
+              <a:t>• </a:t>
+            </a:r>
+            <a:r>
+              <a:rPr sz="1300">
+                <a:solidFill>
+                  <a:srgbClr val="222222"/>
+                </a:solidFill>
+                <a:latin typeface="Calibri"/>
+              </a:rPr>
+              <a:t>Annualization for peer comparison uses program-specific terms-per-year (from the Information Sheet plus empirical seasonal distribution) rather than a blanket 2-term assumption. This corrects a ~33% understatement for 3-term programs such as MDP and Data Science.</a:t>
+            </a:r>
+          </a:p>
+        </p:txBody>
+      </p:sp>
+      <p:sp>
+        <p:nvSpPr>
+          <p:cNvPr id="10" name="TextBox 9"/>
+          <p:cNvSpPr txBox="1"/>
+          <p:nvPr/>
+        </p:nvSpPr>
+        <p:spPr>
+          <a:xfrm>
+            <a:off x="457200" y="5166360"/>
+            <a:ext cx="11277295" cy="822960"/>
+          </a:xfrm>
+          <a:prstGeom prst="rect">
+            <a:avLst/>
+          </a:prstGeom>
+          <a:noFill/>
+        </p:spPr>
+        <p:txBody>
+          <a:bodyPr wrap="square">
+            <a:spAutoFit/>
+          </a:bodyPr>
+          <a:lstStyle/>
+          <a:p>
+            <a:r>
+              <a:rPr sz="1400" b="1">
+                <a:solidFill>
+                  <a:srgbClr val="F2A900"/>
+                </a:solidFill>
+                <a:latin typeface="Calibri"/>
+              </a:rPr>
+              <a:t>• </a:t>
+            </a:r>
+            <a:r>
+              <a:rPr sz="1300">
+                <a:solidFill>
+                  <a:srgbClr val="222222"/>
+                </a:solidFill>
+                <a:latin typeface="Calibri"/>
+              </a:rPr>
+              <a:t>Programs with zero kept scholarship (Data Science, MBID) are retained in the summary with a 0% discount rate — this is intentional and flags potential pricing discrepancies.</a:t>
+            </a:r>
+          </a:p>
+        </p:txBody>
+      </p:sp>
+      <p:sp>
+        <p:nvSpPr>
+          <p:cNvPr id="11" name="TextBox 10"/>
+          <p:cNvSpPr txBox="1"/>
+          <p:nvPr/>
+        </p:nvSpPr>
+        <p:spPr>
+          <a:xfrm>
+            <a:off x="457200" y="5943600"/>
+            <a:ext cx="11277295" cy="822960"/>
+          </a:xfrm>
+          <a:prstGeom prst="rect">
+            <a:avLst/>
+          </a:prstGeom>
+          <a:noFill/>
+        </p:spPr>
+        <p:txBody>
+          <a:bodyPr wrap="square">
+            <a:spAutoFit/>
+          </a:bodyPr>
+          <a:lstStyle/>
+          <a:p>
+            <a:r>
+              <a:rPr sz="1400" b="1">
+                <a:solidFill>
+                  <a:srgbClr val="F2A900"/>
+                </a:solidFill>
+                <a:latin typeface="Calibri"/>
+              </a:rPr>
+              <a:t>• </a:t>
+            </a:r>
+            <a:r>
+              <a:rPr sz="1300">
+                <a:solidFill>
+                  <a:srgbClr val="222222"/>
+                </a:solidFill>
+                <a:latin typeface="Calibri"/>
+              </a:rPr>
+              <a:t>v2 pricing filter (df_pricing): avg gross/net tuition, discount rate, and peer benchmark exclude 11 of 493 student-program rows with total billed tuition under $20,000. These reflect single-course or partial-term billings with ~$0 scholarship that were depressing averages and compressing the gross-vs-net gap. Enrollment counts, international mix, and per-year trend charts continue to use the full population.</a:t>
+            </a:r>
+          </a:p>
+        </p:txBody>
+      </p:sp>
+    </p:spTree>
+  </p:cSld>
+  <p:clrMapOvr>
+    <a:masterClrMapping/>
+  </p:clrMapOvr>
+</p:sld>
+</file>
+
 <file path=ppt/slides/slide2.xml><?xml version="1.0" encoding="utf-8"?>
 <p:sld xmlns:a="http://schemas.openxmlformats.org/drawingml/2006/main" xmlns:p="http://schemas.openxmlformats.org/presentationml/2006/main" xmlns:r="http://schemas.openxmlformats.org/officeDocument/2006/relationships">
   <p:cSld>
@@ -4158,7 +4798,7 @@
                 </a:solidFill>
                 <a:latin typeface="Calibri"/>
               </a:rPr>
-              <a:t>Per-semester billing is consistent Fall/Spring — Summer reveals MDP's heaviest discounting</a:t>
+              <a:t>Fall billing is tight across programs — Economics discounts most at the per-semester level</a:t>
             </a:r>
           </a:p>
         </p:txBody>
@@ -4193,7 +4833,7 @@
                 </a:solidFill>
                 <a:latin typeface="Calibri"/>
               </a:rPr>
-              <a:t>Charts sorted by Fall gross tuition for easy cross-semester comparison. df_pricing population (gross tuition ≥ $20k).</a:t>
+              <a:t>df_pricing population (gross tuition ≥ $20k). Sorted by Fall gross tuition.</a:t>
             </a:r>
           </a:p>
         </p:txBody>
@@ -4214,65 +4854,17 @@
         </p:blipFill>
         <p:spPr>
           <a:xfrm>
-            <a:off x="4343400" y="274320"/>
-            <a:ext cx="7573975" cy="1993392"/>
+            <a:off x="4343400" y="1271930"/>
+            <a:ext cx="7573975" cy="4131259"/>
           </a:xfrm>
           <a:prstGeom prst="rect">
             <a:avLst/>
           </a:prstGeom>
         </p:spPr>
       </p:pic>
-      <p:pic>
-        <p:nvPicPr>
-          <p:cNvPr id="7" name="Picture 6" descr="gross_net_spring.png"/>
-          <p:cNvPicPr>
-            <a:picLocks noChangeAspect="1"/>
-          </p:cNvPicPr>
-          <p:nvPr/>
-        </p:nvPicPr>
-        <p:blipFill>
-          <a:blip r:embed="rId3"/>
-          <a:stretch>
-            <a:fillRect/>
-          </a:stretch>
-        </p:blipFill>
-        <p:spPr>
-          <a:xfrm>
-            <a:off x="4343400" y="2340864"/>
-            <a:ext cx="7573975" cy="1993392"/>
-          </a:xfrm>
-          <a:prstGeom prst="rect">
-            <a:avLst/>
-          </a:prstGeom>
-        </p:spPr>
-      </p:pic>
-      <p:pic>
-        <p:nvPicPr>
-          <p:cNvPr id="8" name="Picture 7" descr="gross_net_summer.png"/>
-          <p:cNvPicPr>
-            <a:picLocks noChangeAspect="1"/>
-          </p:cNvPicPr>
-          <p:nvPr/>
-        </p:nvPicPr>
-        <p:blipFill>
-          <a:blip r:embed="rId4"/>
-          <a:stretch>
-            <a:fillRect/>
-          </a:stretch>
-        </p:blipFill>
-        <p:spPr>
-          <a:xfrm>
-            <a:off x="4343400" y="4407408"/>
-            <a:ext cx="7573975" cy="1993392"/>
-          </a:xfrm>
-          <a:prstGeom prst="rect">
-            <a:avLst/>
-          </a:prstGeom>
-        </p:spPr>
-      </p:pic>
-      <p:sp>
-        <p:nvSpPr>
-          <p:cNvPr id="9" name="TextBox 8"/>
+      <p:sp>
+        <p:nvSpPr>
+          <p:cNvPr id="7" name="TextBox 6"/>
           <p:cNvSpPr txBox="1"/>
           <p:nvPr/>
         </p:nvSpPr>
@@ -4332,7 +4924,7 @@
         <p:spPr>
           <a:xfrm>
             <a:off x="0" y="0"/>
-            <a:ext cx="12191695" cy="1188720"/>
+            <a:ext cx="4114800" cy="6858000"/>
           </a:xfrm>
           <a:prstGeom prst="rect">
             <a:avLst/>
@@ -4368,49 +4960,14 @@
       </p:sp>
       <p:sp>
         <p:nvSpPr>
-          <p:cNvPr id="3" name="TextBox 2"/>
-          <p:cNvSpPr txBox="1"/>
-          <p:nvPr/>
-        </p:nvSpPr>
-        <p:spPr>
-          <a:xfrm>
-            <a:off x="457200" y="228600"/>
-            <a:ext cx="11277295" cy="777240"/>
-          </a:xfrm>
-          <a:prstGeom prst="rect">
-            <a:avLst/>
-          </a:prstGeom>
-          <a:noFill/>
-        </p:spPr>
-        <p:txBody>
-          <a:bodyPr wrap="square">
-            <a:spAutoFit/>
-          </a:bodyPr>
-          <a:lstStyle/>
-          <a:p>
-            <a:pPr algn="l"/>
-            <a:r>
-              <a:rPr sz="2000" b="1">
-                <a:solidFill>
-                  <a:srgbClr val="FFFFFF"/>
-                </a:solidFill>
-                <a:latin typeface="Calibri"/>
-              </a:rPr>
-              <a:t>High international share doesn't come with lower aid — Computer Science is 86% international AND 49% discounted</a:t>
-            </a:r>
-          </a:p>
-        </p:txBody>
-      </p:sp>
-      <p:sp>
-        <p:nvSpPr>
-          <p:cNvPr id="4" name="Rectangle 3"/>
+          <p:cNvPr id="3" name="Rectangle 2"/>
           <p:cNvSpPr/>
           <p:nvPr/>
         </p:nvSpPr>
         <p:spPr>
           <a:xfrm>
-            <a:off x="0" y="1188720"/>
-            <a:ext cx="12191695" cy="54864"/>
+            <a:off x="4114800" y="0"/>
+            <a:ext cx="54864" cy="6858000"/>
           </a:xfrm>
           <a:prstGeom prst="rect">
             <a:avLst/>
@@ -4444,9 +5001,79 @@
           </a:p>
         </p:txBody>
       </p:sp>
+      <p:sp>
+        <p:nvSpPr>
+          <p:cNvPr id="4" name="TextBox 3"/>
+          <p:cNvSpPr txBox="1"/>
+          <p:nvPr/>
+        </p:nvSpPr>
+        <p:spPr>
+          <a:xfrm>
+            <a:off x="365760" y="914400"/>
+            <a:ext cx="3474720" cy="3657600"/>
+          </a:xfrm>
+          <a:prstGeom prst="rect">
+            <a:avLst/>
+          </a:prstGeom>
+          <a:noFill/>
+        </p:spPr>
+        <p:txBody>
+          <a:bodyPr wrap="square">
+            <a:spAutoFit/>
+          </a:bodyPr>
+          <a:lstStyle/>
+          <a:p>
+            <a:pPr algn="l"/>
+            <a:r>
+              <a:rPr sz="2000" b="1">
+                <a:solidFill>
+                  <a:srgbClr val="FFFFFF"/>
+                </a:solidFill>
+                <a:latin typeface="Calibri"/>
+              </a:rPr>
+              <a:t>Spring mirrors Fall with one exception — CS 4+1 shows the largest proportional discount</a:t>
+            </a:r>
+          </a:p>
+        </p:txBody>
+      </p:sp>
+      <p:sp>
+        <p:nvSpPr>
+          <p:cNvPr id="5" name="TextBox 4"/>
+          <p:cNvSpPr txBox="1"/>
+          <p:nvPr/>
+        </p:nvSpPr>
+        <p:spPr>
+          <a:xfrm>
+            <a:off x="365760" y="4937760"/>
+            <a:ext cx="3474720" cy="1463040"/>
+          </a:xfrm>
+          <a:prstGeom prst="rect">
+            <a:avLst/>
+          </a:prstGeom>
+          <a:noFill/>
+        </p:spPr>
+        <p:txBody>
+          <a:bodyPr wrap="square">
+            <a:spAutoFit/>
+          </a:bodyPr>
+          <a:lstStyle/>
+          <a:p>
+            <a:pPr algn="l"/>
+            <a:r>
+              <a:rPr sz="1300" b="0">
+                <a:solidFill>
+                  <a:srgbClr val="F2A900"/>
+                </a:solidFill>
+                <a:latin typeface="Calibri"/>
+              </a:rPr>
+              <a:t>df_pricing population (gross tuition ≥ $20k). Sorted by Fall gross tuition.</a:t>
+            </a:r>
+          </a:p>
+        </p:txBody>
+      </p:sp>
       <p:pic>
         <p:nvPicPr>
-          <p:cNvPr id="5" name="Picture 4" descr="03_intl_pct_vs_discount_rate.png"/>
+          <p:cNvPr id="6" name="Picture 5" descr="gross_net_spring.png"/>
           <p:cNvPicPr>
             <a:picLocks noChangeAspect="1"/>
           </p:cNvPicPr>
@@ -4460,8 +5087,8 @@
         </p:blipFill>
         <p:spPr>
           <a:xfrm>
-            <a:off x="457200" y="1463040"/>
-            <a:ext cx="11277295" cy="5029200"/>
+            <a:off x="4343400" y="1271930"/>
+            <a:ext cx="7573975" cy="4131259"/>
           </a:xfrm>
           <a:prstGeom prst="rect">
             <a:avLst/>
@@ -4470,7 +5097,7 @@
       </p:pic>
       <p:sp>
         <p:nvSpPr>
-          <p:cNvPr id="6" name="TextBox 5"/>
+          <p:cNvPr id="7" name="TextBox 6"/>
           <p:cNvSpPr txBox="1"/>
           <p:nvPr/>
         </p:nvSpPr>
@@ -4530,7 +5157,7 @@
         <p:spPr>
           <a:xfrm>
             <a:off x="0" y="0"/>
-            <a:ext cx="12191695" cy="1188720"/>
+            <a:ext cx="4114800" cy="6858000"/>
           </a:xfrm>
           <a:prstGeom prst="rect">
             <a:avLst/>
@@ -4566,49 +5193,14 @@
       </p:sp>
       <p:sp>
         <p:nvSpPr>
-          <p:cNvPr id="3" name="TextBox 2"/>
-          <p:cNvSpPr txBox="1"/>
-          <p:nvPr/>
-        </p:nvSpPr>
-        <p:spPr>
-          <a:xfrm>
-            <a:off x="457200" y="228600"/>
-            <a:ext cx="11277295" cy="777240"/>
-          </a:xfrm>
-          <a:prstGeom prst="rect">
-            <a:avLst/>
-          </a:prstGeom>
-          <a:noFill/>
-        </p:spPr>
-        <p:txBody>
-          <a:bodyPr wrap="square">
-            <a:spAutoFit/>
-          </a:bodyPr>
-          <a:lstStyle/>
-          <a:p>
-            <a:pPr algn="l"/>
-            <a:r>
-              <a:rPr sz="2000" b="1">
-                <a:solidFill>
-                  <a:srgbClr val="FFFFFF"/>
-                </a:solidFill>
-                <a:latin typeface="Calibri"/>
-              </a:rPr>
-              <a:t>Computer Science enrollment has roughly doubled since 2022 — driving nearly all of Emory's LGS master's volume growth</a:t>
-            </a:r>
-          </a:p>
-        </p:txBody>
-      </p:sp>
-      <p:sp>
-        <p:nvSpPr>
-          <p:cNvPr id="4" name="Rectangle 3"/>
+          <p:cNvPr id="3" name="Rectangle 2"/>
           <p:cNvSpPr/>
           <p:nvPr/>
         </p:nvSpPr>
         <p:spPr>
           <a:xfrm>
-            <a:off x="0" y="1188720"/>
-            <a:ext cx="12191695" cy="54864"/>
+            <a:off x="4114800" y="0"/>
+            <a:ext cx="54864" cy="6858000"/>
           </a:xfrm>
           <a:prstGeom prst="rect">
             <a:avLst/>
@@ -4642,9 +5234,79 @@
           </a:p>
         </p:txBody>
       </p:sp>
+      <p:sp>
+        <p:nvSpPr>
+          <p:cNvPr id="4" name="TextBox 3"/>
+          <p:cNvSpPr txBox="1"/>
+          <p:nvPr/>
+        </p:nvSpPr>
+        <p:spPr>
+          <a:xfrm>
+            <a:off x="365760" y="914400"/>
+            <a:ext cx="3474720" cy="3657600"/>
+          </a:xfrm>
+          <a:prstGeom prst="rect">
+            <a:avLst/>
+          </a:prstGeom>
+          <a:noFill/>
+        </p:spPr>
+        <p:txBody>
+          <a:bodyPr wrap="square">
+            <a:spAutoFit/>
+          </a:bodyPr>
+          <a:lstStyle/>
+          <a:p>
+            <a:pPr algn="l"/>
+            <a:r>
+              <a:rPr sz="2000" b="1">
+                <a:solidFill>
+                  <a:srgbClr val="FFFFFF"/>
+                </a:solidFill>
+                <a:latin typeface="Calibri"/>
+              </a:rPr>
+              <a:t>Summer is where MDP's scholarship strategy concentrates — near-zero net on $22k gross</a:t>
+            </a:r>
+          </a:p>
+        </p:txBody>
+      </p:sp>
+      <p:sp>
+        <p:nvSpPr>
+          <p:cNvPr id="5" name="TextBox 4"/>
+          <p:cNvSpPr txBox="1"/>
+          <p:nvPr/>
+        </p:nvSpPr>
+        <p:spPr>
+          <a:xfrm>
+            <a:off x="365760" y="4937760"/>
+            <a:ext cx="3474720" cy="1463040"/>
+          </a:xfrm>
+          <a:prstGeom prst="rect">
+            <a:avLst/>
+          </a:prstGeom>
+          <a:noFill/>
+        </p:spPr>
+        <p:txBody>
+          <a:bodyPr wrap="square">
+            <a:spAutoFit/>
+          </a:bodyPr>
+          <a:lstStyle/>
+          <a:p>
+            <a:pPr algn="l"/>
+            <a:r>
+              <a:rPr sz="1300" b="0">
+                <a:solidFill>
+                  <a:srgbClr val="F2A900"/>
+                </a:solidFill>
+                <a:latin typeface="Calibri"/>
+              </a:rPr>
+              <a:t>df_pricing population (gross tuition ≥ $20k). Sorted by Fall gross tuition.</a:t>
+            </a:r>
+          </a:p>
+        </p:txBody>
+      </p:sp>
       <p:pic>
         <p:nvPicPr>
-          <p:cNvPr id="5" name="Picture 4" descr="04_enrollment_trend_by_program.png"/>
+          <p:cNvPr id="6" name="Picture 5" descr="gross_net_summer.png"/>
           <p:cNvPicPr>
             <a:picLocks noChangeAspect="1"/>
           </p:cNvPicPr>
@@ -4658,8 +5320,8 @@
         </p:blipFill>
         <p:spPr>
           <a:xfrm>
-            <a:off x="457200" y="1463040"/>
-            <a:ext cx="11277295" cy="5029200"/>
+            <a:off x="4343400" y="1271930"/>
+            <a:ext cx="7573975" cy="4131259"/>
           </a:xfrm>
           <a:prstGeom prst="rect">
             <a:avLst/>
@@ -4668,7 +5330,7 @@
       </p:pic>
       <p:sp>
         <p:nvSpPr>
-          <p:cNvPr id="6" name="TextBox 5"/>
+          <p:cNvPr id="7" name="TextBox 6"/>
           <p:cNvSpPr txBox="1"/>
           <p:nvPr/>
         </p:nvSpPr>
@@ -4792,7 +5454,7 @@
                 </a:solidFill>
                 <a:latin typeface="Calibri"/>
               </a:rPr>
-              <a:t>Discount rates are broadly stable year-over-year — no program is systematically tightening aid</a:t>
+              <a:t>High international share doesn't come with lower aid — Computer Science is 86% international AND 49% discounted</a:t>
             </a:r>
           </a:p>
         </p:txBody>
@@ -4842,7 +5504,7 @@
       </p:sp>
       <p:pic>
         <p:nvPicPr>
-          <p:cNvPr id="5" name="Picture 4" descr="05_discount_rate_trend_by_program.png"/>
+          <p:cNvPr id="5" name="Picture 4" descr="03_intl_pct_vs_discount_rate.png"/>
           <p:cNvPicPr>
             <a:picLocks noChangeAspect="1"/>
           </p:cNvPicPr>
@@ -4990,7 +5652,7 @@
                 </a:solidFill>
                 <a:latin typeface="Calibri"/>
               </a:rPr>
-              <a:t>Emory's annualized tuition ($47–51k) undercuts Columbia/NYU by $20–40k and sits above Georgia Tech's in-state rates — mid-market positioning</a:t>
+              <a:t>Computer Science enrollment has roughly doubled since 2022 — driving nearly all of Emory's LGS master's volume growth</a:t>
             </a:r>
           </a:p>
         </p:txBody>
@@ -5040,7 +5702,7 @@
       </p:sp>
       <p:pic>
         <p:nvPicPr>
-          <p:cNvPr id="5" name="Picture 4" descr="06_peer_benchmark_emory_vs_peers.png"/>
+          <p:cNvPr id="5" name="Picture 4" descr="04_enrollment_trend_by_program.png"/>
           <p:cNvPicPr>
             <a:picLocks noChangeAspect="1"/>
           </p:cNvPicPr>
@@ -5124,7 +5786,7 @@
         <p:spPr>
           <a:xfrm>
             <a:off x="0" y="0"/>
-            <a:ext cx="12191695" cy="914400"/>
+            <a:ext cx="12191695" cy="1188720"/>
           </a:xfrm>
           <a:prstGeom prst="rect">
             <a:avLst/>
@@ -5166,8 +5828,8 @@
         </p:nvSpPr>
         <p:spPr>
           <a:xfrm>
-            <a:off x="457200" y="182880"/>
-            <a:ext cx="11277295" cy="640080"/>
+            <a:off x="457200" y="228600"/>
+            <a:ext cx="11277295" cy="777240"/>
           </a:xfrm>
           <a:prstGeom prst="rect">
             <a:avLst/>
@@ -5182,13 +5844,13 @@
           <a:p>
             <a:pPr algn="l"/>
             <a:r>
-              <a:rPr sz="2600" b="1">
+              <a:rPr sz="2000" b="1">
                 <a:solidFill>
                   <a:srgbClr val="FFFFFF"/>
                 </a:solidFill>
                 <a:latin typeface="Calibri"/>
               </a:rPr>
-              <a:t>Data Notes &amp; Methodology</a:t>
+              <a:t>Discount rates are broadly stable year-over-year — no program is systematically tightening aid</a:t>
             </a:r>
           </a:p>
         </p:txBody>
@@ -5201,8 +5863,8 @@
         </p:nvSpPr>
         <p:spPr>
           <a:xfrm>
-            <a:off x="0" y="914400"/>
-            <a:ext cx="12191695" cy="73152"/>
+            <a:off x="0" y="1188720"/>
+            <a:ext cx="12191695" cy="54864"/>
           </a:xfrm>
           <a:prstGeom prst="rect">
             <a:avLst/>
@@ -5236,16 +5898,40 @@
           </a:p>
         </p:txBody>
       </p:sp>
-      <p:sp>
-        <p:nvSpPr>
-          <p:cNvPr id="5" name="TextBox 4"/>
+      <p:pic>
+        <p:nvPicPr>
+          <p:cNvPr id="5" name="Picture 4" descr="05_discount_rate_trend_by_program.png"/>
+          <p:cNvPicPr>
+            <a:picLocks noChangeAspect="1"/>
+          </p:cNvPicPr>
+          <p:nvPr/>
+        </p:nvPicPr>
+        <p:blipFill>
+          <a:blip r:embed="rId2"/>
+          <a:stretch>
+            <a:fillRect/>
+          </a:stretch>
+        </p:blipFill>
+        <p:spPr>
+          <a:xfrm>
+            <a:off x="457200" y="1463040"/>
+            <a:ext cx="11277295" cy="5029200"/>
+          </a:xfrm>
+          <a:prstGeom prst="rect">
+            <a:avLst/>
+          </a:prstGeom>
+        </p:spPr>
+      </p:pic>
+      <p:sp>
+        <p:nvSpPr>
+          <p:cNvPr id="6" name="TextBox 5"/>
           <p:cNvSpPr txBox="1"/>
           <p:nvPr/>
         </p:nvSpPr>
         <p:spPr>
           <a:xfrm>
-            <a:off x="457200" y="1280160"/>
-            <a:ext cx="11277295" cy="822960"/>
+            <a:off x="11460175" y="6537960"/>
+            <a:ext cx="548640" cy="274320"/>
           </a:xfrm>
           <a:prstGeom prst="rect">
             <a:avLst/>
@@ -5258,281 +5944,15 @@
           </a:bodyPr>
           <a:lstStyle/>
           <a:p>
-            <a:r>
-              <a:rPr sz="1400" b="1">
-                <a:solidFill>
-                  <a:srgbClr val="F2A900"/>
+            <a:pPr algn="r"/>
+            <a:r>
+              <a:rPr sz="1100" b="0">
+                <a:solidFill>
+                  <a:srgbClr val="012169"/>
                 </a:solidFill>
                 <a:latin typeface="Calibri"/>
               </a:rPr>
-              <a:t>• </a:t>
-            </a:r>
-            <a:r>
-              <a:rPr sz="1300">
-                <a:solidFill>
-                  <a:srgbClr val="222222"/>
-                </a:solidFill>
-                <a:latin typeface="Calibri"/>
-              </a:rPr>
-              <a:t>Source data: institutional Excel exports of gross tuition billed and LGS scholarship awards; 8-year panel spanning AY 2019 through AY 2026.</a:t>
-            </a:r>
-          </a:p>
-        </p:txBody>
-      </p:sp>
-      <p:sp>
-        <p:nvSpPr>
-          <p:cNvPr id="6" name="TextBox 5"/>
-          <p:cNvSpPr txBox="1"/>
-          <p:nvPr/>
-        </p:nvSpPr>
-        <p:spPr>
-          <a:xfrm>
-            <a:off x="457200" y="2057400"/>
-            <a:ext cx="11277295" cy="822960"/>
-          </a:xfrm>
-          <a:prstGeom prst="rect">
-            <a:avLst/>
-          </a:prstGeom>
-          <a:noFill/>
-        </p:spPr>
-        <p:txBody>
-          <a:bodyPr wrap="square">
-            <a:spAutoFit/>
-          </a:bodyPr>
-          <a:lstStyle/>
-          <a:p>
-            <a:r>
-              <a:rPr sz="1400" b="1">
-                <a:solidFill>
-                  <a:srgbClr val="F2A900"/>
-                </a:solidFill>
-                <a:latin typeface="Calibri"/>
-              </a:rPr>
-              <a:t>• </a:t>
-            </a:r>
-            <a:r>
-              <a:rPr sz="1300">
-                <a:solidFill>
-                  <a:srgbClr val="222222"/>
-                </a:solidFill>
-                <a:latin typeface="Calibri"/>
-              </a:rPr>
-              <a:t>Net tuition is clipped at zero. In rare cases a kept scholarship exceeds billed tuition for a partial-term student; we report that student as paying $0 rather than a negative amount.</a:t>
-            </a:r>
-          </a:p>
-        </p:txBody>
-      </p:sp>
-      <p:sp>
-        <p:nvSpPr>
-          <p:cNvPr id="7" name="TextBox 6"/>
-          <p:cNvSpPr txBox="1"/>
-          <p:nvPr/>
-        </p:nvSpPr>
-        <p:spPr>
-          <a:xfrm>
-            <a:off x="457200" y="2834640"/>
-            <a:ext cx="11277295" cy="822960"/>
-          </a:xfrm>
-          <a:prstGeom prst="rect">
-            <a:avLst/>
-          </a:prstGeom>
-          <a:noFill/>
-        </p:spPr>
-        <p:txBody>
-          <a:bodyPr wrap="square">
-            <a:spAutoFit/>
-          </a:bodyPr>
-          <a:lstStyle/>
-          <a:p>
-            <a:r>
-              <a:rPr sz="1400" b="1">
-                <a:solidFill>
-                  <a:srgbClr val="F2A900"/>
-                </a:solidFill>
-                <a:latin typeface="Calibri"/>
-              </a:rPr>
-              <a:t>• </a:t>
-            </a:r>
-            <a:r>
-              <a:rPr sz="1300">
-                <a:solidFill>
-                  <a:srgbClr val="222222"/>
-                </a:solidFill>
-                <a:latin typeface="Calibri"/>
-              </a:rPr>
-              <a:t>Scholarship filter retains descriptions containing 'lgs' and drops external/federal awards (Pell, GRFP, Yellow Ribbon, Americorps, etc.) plus generic LGS 'special' awards, so discount rates reflect institutional aid only.</a:t>
-            </a:r>
-          </a:p>
-        </p:txBody>
-      </p:sp>
-      <p:sp>
-        <p:nvSpPr>
-          <p:cNvPr id="8" name="TextBox 7"/>
-          <p:cNvSpPr txBox="1"/>
-          <p:nvPr/>
-        </p:nvSpPr>
-        <p:spPr>
-          <a:xfrm>
-            <a:off x="457200" y="3611880"/>
-            <a:ext cx="11277295" cy="822960"/>
-          </a:xfrm>
-          <a:prstGeom prst="rect">
-            <a:avLst/>
-          </a:prstGeom>
-          <a:noFill/>
-        </p:spPr>
-        <p:txBody>
-          <a:bodyPr wrap="square">
-            <a:spAutoFit/>
-          </a:bodyPr>
-          <a:lstStyle/>
-          <a:p>
-            <a:r>
-              <a:rPr sz="1400" b="1">
-                <a:solidFill>
-                  <a:srgbClr val="F2A900"/>
-                </a:solidFill>
-                <a:latin typeface="Calibri"/>
-              </a:rPr>
-              <a:t>• </a:t>
-            </a:r>
-            <a:r>
-              <a:rPr sz="1300">
-                <a:solidFill>
-                  <a:srgbClr val="222222"/>
-                </a:solidFill>
-                <a:latin typeface="Calibri"/>
-              </a:rPr>
-              <a:t>Small-n programs are merged: ECONMS + ECON4P1MS → Economics; DATASCIMS + QTMMS → Data Science; DEVPRACMDP + HUMANRTCRT → MDP.</a:t>
-            </a:r>
-          </a:p>
-        </p:txBody>
-      </p:sp>
-      <p:sp>
-        <p:nvSpPr>
-          <p:cNvPr id="9" name="TextBox 8"/>
-          <p:cNvSpPr txBox="1"/>
-          <p:nvPr/>
-        </p:nvSpPr>
-        <p:spPr>
-          <a:xfrm>
-            <a:off x="457200" y="4389120"/>
-            <a:ext cx="11277295" cy="822960"/>
-          </a:xfrm>
-          <a:prstGeom prst="rect">
-            <a:avLst/>
-          </a:prstGeom>
-          <a:noFill/>
-        </p:spPr>
-        <p:txBody>
-          <a:bodyPr wrap="square">
-            <a:spAutoFit/>
-          </a:bodyPr>
-          <a:lstStyle/>
-          <a:p>
-            <a:r>
-              <a:rPr sz="1400" b="1">
-                <a:solidFill>
-                  <a:srgbClr val="F2A900"/>
-                </a:solidFill>
-                <a:latin typeface="Calibri"/>
-              </a:rPr>
-              <a:t>• </a:t>
-            </a:r>
-            <a:r>
-              <a:rPr sz="1300">
-                <a:solidFill>
-                  <a:srgbClr val="222222"/>
-                </a:solidFill>
-                <a:latin typeface="Calibri"/>
-              </a:rPr>
-              <a:t>Annualization for peer comparison uses program-specific terms-per-year (from the Information Sheet plus empirical seasonal distribution) rather than a blanket 2-term assumption. This corrects a ~33% understatement for 3-term programs such as MDP and Data Science.</a:t>
-            </a:r>
-          </a:p>
-        </p:txBody>
-      </p:sp>
-      <p:sp>
-        <p:nvSpPr>
-          <p:cNvPr id="10" name="TextBox 9"/>
-          <p:cNvSpPr txBox="1"/>
-          <p:nvPr/>
-        </p:nvSpPr>
-        <p:spPr>
-          <a:xfrm>
-            <a:off x="457200" y="5166360"/>
-            <a:ext cx="11277295" cy="822960"/>
-          </a:xfrm>
-          <a:prstGeom prst="rect">
-            <a:avLst/>
-          </a:prstGeom>
-          <a:noFill/>
-        </p:spPr>
-        <p:txBody>
-          <a:bodyPr wrap="square">
-            <a:spAutoFit/>
-          </a:bodyPr>
-          <a:lstStyle/>
-          <a:p>
-            <a:r>
-              <a:rPr sz="1400" b="1">
-                <a:solidFill>
-                  <a:srgbClr val="F2A900"/>
-                </a:solidFill>
-                <a:latin typeface="Calibri"/>
-              </a:rPr>
-              <a:t>• </a:t>
-            </a:r>
-            <a:r>
-              <a:rPr sz="1300">
-                <a:solidFill>
-                  <a:srgbClr val="222222"/>
-                </a:solidFill>
-                <a:latin typeface="Calibri"/>
-              </a:rPr>
-              <a:t>Programs with zero kept scholarship (Data Science, MBID) are retained in the summary with a 0% discount rate — this is intentional and flags potential pricing discrepancies.</a:t>
-            </a:r>
-          </a:p>
-        </p:txBody>
-      </p:sp>
-      <p:sp>
-        <p:nvSpPr>
-          <p:cNvPr id="11" name="TextBox 10"/>
-          <p:cNvSpPr txBox="1"/>
-          <p:nvPr/>
-        </p:nvSpPr>
-        <p:spPr>
-          <a:xfrm>
-            <a:off x="457200" y="5943600"/>
-            <a:ext cx="11277295" cy="822960"/>
-          </a:xfrm>
-          <a:prstGeom prst="rect">
-            <a:avLst/>
-          </a:prstGeom>
-          <a:noFill/>
-        </p:spPr>
-        <p:txBody>
-          <a:bodyPr wrap="square">
-            <a:spAutoFit/>
-          </a:bodyPr>
-          <a:lstStyle/>
-          <a:p>
-            <a:r>
-              <a:rPr sz="1400" b="1">
-                <a:solidFill>
-                  <a:srgbClr val="F2A900"/>
-                </a:solidFill>
-                <a:latin typeface="Calibri"/>
-              </a:rPr>
-              <a:t>• </a:t>
-            </a:r>
-            <a:r>
-              <a:rPr sz="1300">
-                <a:solidFill>
-                  <a:srgbClr val="222222"/>
-                </a:solidFill>
-                <a:latin typeface="Calibri"/>
-              </a:rPr>
-              <a:t>v2 pricing filter (df_pricing): avg gross/net tuition, discount rate, and peer benchmark exclude 11 of 493 student-program rows with total billed tuition under $20,000. These reflect single-course or partial-term billings with ~$0 scholarship that were depressing averages and compressing the gross-vs-net gap. Enrollment counts, international mix, and per-year trend charts continue to use the full population.</a:t>
+              <a:t>9</a:t>
             </a:r>
           </a:p>
         </p:txBody>

</xml_diff>

<commit_message>
Re-insert Recommendations across deck, report, and speaker notes
Deck: new slide 11 with full-bleed navy background and four
gold-numbered (01–04) recommendation badges, inserted between Peer
Benchmark and Methodology. Methodology shifts to slide 12.

Report: new Section "Recommendations" with four subsections
(6.1–6.4) before Methodology. Subsection rendering now allows a
chart=None so non-chart subsections render with heading + narrative
only.

Speaker notes: new slide-11 entry with paragraph-style "What to say"
content (one paragraph framing the section plus one paragraph per
recommendation), a "Key points" bullet list, and a TIP box.
Methodology heading renumbered to slide 12.

Co-Authored-By: Claude Opus 4.7 (1M context) <noreply@anthropic.com>
</commit_message>
<xml_diff>
--- a/deliverables/emory_grad_pricing_v2.pptx
+++ b/deliverables/emory_grad_pricing_v2.pptx
@@ -16,6 +16,7 @@
     <p:sldId id="264" r:id="rId15"/>
     <p:sldId id="265" r:id="rId16"/>
     <p:sldId id="266" r:id="rId17"/>
+    <p:sldId id="267" r:id="rId18"/>
   </p:sldIdLst>
   <p:sldSz cx="12191695" cy="6858000" type="screen4x3"/>
   <p:notesSz cx="6858000" cy="9144000"/>
@@ -3496,6 +3497,668 @@
 </file>
 
 <file path=ppt/slides/slide11.xml><?xml version="1.0" encoding="utf-8"?>
+<p:sld xmlns:a="http://schemas.openxmlformats.org/drawingml/2006/main" xmlns:p="http://schemas.openxmlformats.org/presentationml/2006/main" xmlns:r="http://schemas.openxmlformats.org/officeDocument/2006/relationships">
+  <p:cSld>
+    <p:spTree>
+      <p:nvGrpSpPr>
+        <p:cNvPr id="1" name=""/>
+        <p:cNvGrpSpPr/>
+        <p:nvPr/>
+      </p:nvGrpSpPr>
+      <p:grpSpPr/>
+      <p:sp>
+        <p:nvSpPr>
+          <p:cNvPr id="2" name="Rectangle 1"/>
+          <p:cNvSpPr/>
+          <p:nvPr/>
+        </p:nvSpPr>
+        <p:spPr>
+          <a:xfrm>
+            <a:off x="0" y="0"/>
+            <a:ext cx="12191695" cy="6858000"/>
+          </a:xfrm>
+          <a:prstGeom prst="rect">
+            <a:avLst/>
+          </a:prstGeom>
+          <a:solidFill>
+            <a:srgbClr val="012169"/>
+          </a:solidFill>
+          <a:ln>
+            <a:noFill/>
+          </a:ln>
+        </p:spPr>
+        <p:style>
+          <a:lnRef idx="1">
+            <a:schemeClr val="accent1"/>
+          </a:lnRef>
+          <a:fillRef idx="3">
+            <a:schemeClr val="accent1"/>
+          </a:fillRef>
+          <a:effectRef idx="2">
+            <a:schemeClr val="accent1"/>
+          </a:effectRef>
+          <a:fontRef idx="minor">
+            <a:schemeClr val="lt1"/>
+          </a:fontRef>
+        </p:style>
+        <p:txBody>
+          <a:bodyPr rtlCol="0" anchor="ctr"/>
+          <a:lstStyle/>
+          <a:p>
+            <a:pPr algn="ctr"/>
+          </a:p>
+        </p:txBody>
+      </p:sp>
+      <p:sp>
+        <p:nvSpPr>
+          <p:cNvPr id="3" name="TextBox 2"/>
+          <p:cNvSpPr txBox="1"/>
+          <p:nvPr/>
+        </p:nvSpPr>
+        <p:spPr>
+          <a:xfrm>
+            <a:off x="548640" y="365760"/>
+            <a:ext cx="11094415" cy="640080"/>
+          </a:xfrm>
+          <a:prstGeom prst="rect">
+            <a:avLst/>
+          </a:prstGeom>
+          <a:noFill/>
+        </p:spPr>
+        <p:txBody>
+          <a:bodyPr wrap="square">
+            <a:spAutoFit/>
+          </a:bodyPr>
+          <a:lstStyle/>
+          <a:p>
+            <a:pPr algn="l"/>
+            <a:r>
+              <a:rPr sz="3000" b="1">
+                <a:solidFill>
+                  <a:srgbClr val="F2A900"/>
+                </a:solidFill>
+                <a:latin typeface="Calibri"/>
+              </a:rPr>
+              <a:t>Recommendations</a:t>
+            </a:r>
+          </a:p>
+        </p:txBody>
+      </p:sp>
+      <p:sp>
+        <p:nvSpPr>
+          <p:cNvPr id="4" name="Rectangle 3"/>
+          <p:cNvSpPr/>
+          <p:nvPr/>
+        </p:nvSpPr>
+        <p:spPr>
+          <a:xfrm>
+            <a:off x="548640" y="1051560"/>
+            <a:ext cx="1371600" cy="54864"/>
+          </a:xfrm>
+          <a:prstGeom prst="rect">
+            <a:avLst/>
+          </a:prstGeom>
+          <a:solidFill>
+            <a:srgbClr val="F2A900"/>
+          </a:solidFill>
+          <a:ln>
+            <a:noFill/>
+          </a:ln>
+        </p:spPr>
+        <p:style>
+          <a:lnRef idx="1">
+            <a:schemeClr val="accent1"/>
+          </a:lnRef>
+          <a:fillRef idx="3">
+            <a:schemeClr val="accent1"/>
+          </a:fillRef>
+          <a:effectRef idx="2">
+            <a:schemeClr val="accent1"/>
+          </a:effectRef>
+          <a:fontRef idx="minor">
+            <a:schemeClr val="lt1"/>
+          </a:fontRef>
+        </p:style>
+        <p:txBody>
+          <a:bodyPr rtlCol="0" anchor="ctr"/>
+          <a:lstStyle/>
+          <a:p>
+            <a:pPr algn="ctr"/>
+          </a:p>
+        </p:txBody>
+      </p:sp>
+      <p:sp>
+        <p:nvSpPr>
+          <p:cNvPr id="5" name="Oval 4"/>
+          <p:cNvSpPr/>
+          <p:nvPr/>
+        </p:nvSpPr>
+        <p:spPr>
+          <a:xfrm>
+            <a:off x="640080" y="1554480"/>
+            <a:ext cx="868680" cy="868680"/>
+          </a:xfrm>
+          <a:prstGeom prst="ellipse">
+            <a:avLst/>
+          </a:prstGeom>
+          <a:solidFill>
+            <a:srgbClr val="F2A900"/>
+          </a:solidFill>
+          <a:ln>
+            <a:noFill/>
+          </a:ln>
+        </p:spPr>
+        <p:style>
+          <a:lnRef idx="1">
+            <a:schemeClr val="accent1"/>
+          </a:lnRef>
+          <a:fillRef idx="3">
+            <a:schemeClr val="accent1"/>
+          </a:fillRef>
+          <a:effectRef idx="2">
+            <a:schemeClr val="accent1"/>
+          </a:effectRef>
+          <a:fontRef idx="minor">
+            <a:schemeClr val="lt1"/>
+          </a:fontRef>
+        </p:style>
+        <p:txBody>
+          <a:bodyPr rtlCol="0" anchor="ctr" lIns="0" rIns="0" tIns="0" bIns="0"/>
+          <a:lstStyle/>
+          <a:p>
+            <a:pPr algn="ctr"/>
+            <a:r>
+              <a:rPr sz="2400" b="1">
+                <a:solidFill>
+                  <a:srgbClr val="012169"/>
+                </a:solidFill>
+                <a:latin typeface="Calibri"/>
+              </a:rPr>
+              <a:t>01</a:t>
+            </a:r>
+          </a:p>
+        </p:txBody>
+      </p:sp>
+      <p:sp>
+        <p:nvSpPr>
+          <p:cNvPr id="6" name="TextBox 5"/>
+          <p:cNvSpPr txBox="1"/>
+          <p:nvPr/>
+        </p:nvSpPr>
+        <p:spPr>
+          <a:xfrm>
+            <a:off x="1828800" y="1508760"/>
+            <a:ext cx="9814255" cy="411480"/>
+          </a:xfrm>
+          <a:prstGeom prst="rect">
+            <a:avLst/>
+          </a:prstGeom>
+          <a:noFill/>
+        </p:spPr>
+        <p:txBody>
+          <a:bodyPr wrap="square">
+            <a:spAutoFit/>
+          </a:bodyPr>
+          <a:lstStyle/>
+          <a:p>
+            <a:pPr algn="l"/>
+            <a:r>
+              <a:rPr sz="1600" b="1">
+                <a:solidFill>
+                  <a:srgbClr val="F2A900"/>
+                </a:solidFill>
+                <a:latin typeface="Calibri"/>
+              </a:rPr>
+              <a:t>Audit Data Science &amp; MBID scholarship eligibility</a:t>
+            </a:r>
+          </a:p>
+        </p:txBody>
+      </p:sp>
+      <p:sp>
+        <p:nvSpPr>
+          <p:cNvPr id="7" name="TextBox 6"/>
+          <p:cNvSpPr txBox="1"/>
+          <p:nvPr/>
+        </p:nvSpPr>
+        <p:spPr>
+          <a:xfrm>
+            <a:off x="1828800" y="1920240"/>
+            <a:ext cx="9814255" cy="777240"/>
+          </a:xfrm>
+          <a:prstGeom prst="rect">
+            <a:avLst/>
+          </a:prstGeom>
+          <a:noFill/>
+        </p:spPr>
+        <p:txBody>
+          <a:bodyPr wrap="square">
+            <a:spAutoFit/>
+          </a:bodyPr>
+          <a:lstStyle/>
+          <a:p>
+            <a:pPr algn="l"/>
+            <a:r>
+              <a:rPr sz="1100" b="0">
+                <a:solidFill>
+                  <a:srgbClr val="FFFFFF"/>
+                </a:solidFill>
+                <a:latin typeface="Calibri"/>
+              </a:rPr>
+              <a:t>Both programs show 0% kept LGS scholarship across the 8-year panel (Data Science n=11, MBID n=8). Reconcile the raw FA ledger against the filtered scholarship feed to confirm whether this is a data anomaly or a deliberate full-pay carve-out — and if deliberate, decide whether it is costing yield against discounted peers.</a:t>
+            </a:r>
+          </a:p>
+        </p:txBody>
+      </p:sp>
+      <p:sp>
+        <p:nvSpPr>
+          <p:cNvPr id="8" name="Oval 7"/>
+          <p:cNvSpPr/>
+          <p:nvPr/>
+        </p:nvSpPr>
+        <p:spPr>
+          <a:xfrm>
+            <a:off x="640080" y="2834640"/>
+            <a:ext cx="868680" cy="868680"/>
+          </a:xfrm>
+          <a:prstGeom prst="ellipse">
+            <a:avLst/>
+          </a:prstGeom>
+          <a:solidFill>
+            <a:srgbClr val="F2A900"/>
+          </a:solidFill>
+          <a:ln>
+            <a:noFill/>
+          </a:ln>
+        </p:spPr>
+        <p:style>
+          <a:lnRef idx="1">
+            <a:schemeClr val="accent1"/>
+          </a:lnRef>
+          <a:fillRef idx="3">
+            <a:schemeClr val="accent1"/>
+          </a:fillRef>
+          <a:effectRef idx="2">
+            <a:schemeClr val="accent1"/>
+          </a:effectRef>
+          <a:fontRef idx="minor">
+            <a:schemeClr val="lt1"/>
+          </a:fontRef>
+        </p:style>
+        <p:txBody>
+          <a:bodyPr rtlCol="0" anchor="ctr" lIns="0" rIns="0" tIns="0" bIns="0"/>
+          <a:lstStyle/>
+          <a:p>
+            <a:pPr algn="ctr"/>
+            <a:r>
+              <a:rPr sz="2400" b="1">
+                <a:solidFill>
+                  <a:srgbClr val="012169"/>
+                </a:solidFill>
+                <a:latin typeface="Calibri"/>
+              </a:rPr>
+              <a:t>02</a:t>
+            </a:r>
+          </a:p>
+        </p:txBody>
+      </p:sp>
+      <p:sp>
+        <p:nvSpPr>
+          <p:cNvPr id="9" name="TextBox 8"/>
+          <p:cNvSpPr txBox="1"/>
+          <p:nvPr/>
+        </p:nvSpPr>
+        <p:spPr>
+          <a:xfrm>
+            <a:off x="1828800" y="2788920"/>
+            <a:ext cx="9814255" cy="411480"/>
+          </a:xfrm>
+          <a:prstGeom prst="rect">
+            <a:avLst/>
+          </a:prstGeom>
+          <a:noFill/>
+        </p:spPr>
+        <p:txBody>
+          <a:bodyPr wrap="square">
+            <a:spAutoFit/>
+          </a:bodyPr>
+          <a:lstStyle/>
+          <a:p>
+            <a:pPr algn="l"/>
+            <a:r>
+              <a:rPr sz="1600" b="1">
+                <a:solidFill>
+                  <a:srgbClr val="F2A900"/>
+                </a:solidFill>
+                <a:latin typeface="Calibri"/>
+              </a:rPr>
+              <a:t>Review CS aid strategy relative to international demand</a:t>
+            </a:r>
+          </a:p>
+        </p:txBody>
+      </p:sp>
+      <p:sp>
+        <p:nvSpPr>
+          <p:cNvPr id="10" name="TextBox 9"/>
+          <p:cNvSpPr txBox="1"/>
+          <p:nvPr/>
+        </p:nvSpPr>
+        <p:spPr>
+          <a:xfrm>
+            <a:off x="1828800" y="3200400"/>
+            <a:ext cx="9814255" cy="777240"/>
+          </a:xfrm>
+          <a:prstGeom prst="rect">
+            <a:avLst/>
+          </a:prstGeom>
+          <a:noFill/>
+        </p:spPr>
+        <p:txBody>
+          <a:bodyPr wrap="square">
+            <a:spAutoFit/>
+          </a:bodyPr>
+          <a:lstStyle/>
+          <a:p>
+            <a:pPr algn="l"/>
+            <a:r>
+              <a:rPr sz="1100" b="0">
+                <a:solidFill>
+                  <a:srgbClr val="FFFFFF"/>
+                </a:solidFill>
+                <a:latin typeface="Calibri"/>
+              </a:rPr>
+              <a:t>Computer Science is 86% international and still discounts ~49% per student — the highest international share and one of the deepest discounts in the portfolio. Test whether tighter aid materially shifts yield given that Columbia/NYU charge $20–40k more in absolute terms.</a:t>
+            </a:r>
+          </a:p>
+        </p:txBody>
+      </p:sp>
+      <p:sp>
+        <p:nvSpPr>
+          <p:cNvPr id="11" name="Oval 10"/>
+          <p:cNvSpPr/>
+          <p:nvPr/>
+        </p:nvSpPr>
+        <p:spPr>
+          <a:xfrm>
+            <a:off x="640080" y="4114800"/>
+            <a:ext cx="868680" cy="868680"/>
+          </a:xfrm>
+          <a:prstGeom prst="ellipse">
+            <a:avLst/>
+          </a:prstGeom>
+          <a:solidFill>
+            <a:srgbClr val="F2A900"/>
+          </a:solidFill>
+          <a:ln>
+            <a:noFill/>
+          </a:ln>
+        </p:spPr>
+        <p:style>
+          <a:lnRef idx="1">
+            <a:schemeClr val="accent1"/>
+          </a:lnRef>
+          <a:fillRef idx="3">
+            <a:schemeClr val="accent1"/>
+          </a:fillRef>
+          <a:effectRef idx="2">
+            <a:schemeClr val="accent1"/>
+          </a:effectRef>
+          <a:fontRef idx="minor">
+            <a:schemeClr val="lt1"/>
+          </a:fontRef>
+        </p:style>
+        <p:txBody>
+          <a:bodyPr rtlCol="0" anchor="ctr" lIns="0" rIns="0" tIns="0" bIns="0"/>
+          <a:lstStyle/>
+          <a:p>
+            <a:pPr algn="ctr"/>
+            <a:r>
+              <a:rPr sz="2400" b="1">
+                <a:solidFill>
+                  <a:srgbClr val="012169"/>
+                </a:solidFill>
+                <a:latin typeface="Calibri"/>
+              </a:rPr>
+              <a:t>03</a:t>
+            </a:r>
+          </a:p>
+        </p:txBody>
+      </p:sp>
+      <p:sp>
+        <p:nvSpPr>
+          <p:cNvPr id="12" name="TextBox 11"/>
+          <p:cNvSpPr txBox="1"/>
+          <p:nvPr/>
+        </p:nvSpPr>
+        <p:spPr>
+          <a:xfrm>
+            <a:off x="1828800" y="4069080"/>
+            <a:ext cx="9814255" cy="411480"/>
+          </a:xfrm>
+          <a:prstGeom prst="rect">
+            <a:avLst/>
+          </a:prstGeom>
+          <a:noFill/>
+        </p:spPr>
+        <p:txBody>
+          <a:bodyPr wrap="square">
+            <a:spAutoFit/>
+          </a:bodyPr>
+          <a:lstStyle/>
+          <a:p>
+            <a:pPr algn="l"/>
+            <a:r>
+              <a:rPr sz="1600" b="1">
+                <a:solidFill>
+                  <a:srgbClr val="F2A900"/>
+                </a:solidFill>
+                <a:latin typeface="Calibri"/>
+              </a:rPr>
+              <a:t>Capitalize on the peer pricing gap</a:t>
+            </a:r>
+          </a:p>
+        </p:txBody>
+      </p:sp>
+      <p:sp>
+        <p:nvSpPr>
+          <p:cNvPr id="13" name="TextBox 12"/>
+          <p:cNvSpPr txBox="1"/>
+          <p:nvPr/>
+        </p:nvSpPr>
+        <p:spPr>
+          <a:xfrm>
+            <a:off x="1828800" y="4480560"/>
+            <a:ext cx="9814255" cy="777240"/>
+          </a:xfrm>
+          <a:prstGeom prst="rect">
+            <a:avLst/>
+          </a:prstGeom>
+          <a:noFill/>
+        </p:spPr>
+        <p:txBody>
+          <a:bodyPr wrap="square">
+            <a:spAutoFit/>
+          </a:bodyPr>
+          <a:lstStyle/>
+          <a:p>
+            <a:pPr algn="l"/>
+            <a:r>
+              <a:rPr sz="1100" b="0">
+                <a:solidFill>
+                  <a:srgbClr val="FFFFFF"/>
+                </a:solidFill>
+                <a:latin typeface="Calibri"/>
+              </a:rPr>
+              <a:t>Annualized gross tuition ($47–51k) sits well below Columbia/NYU ($65–91k) and clearly above Georgia Tech in-state ($31–41k). With CS enrollment roughly doubling since 2022, demand is responding — modeling selective sticker-price increases in the most-demanded programs (CS, MDP) is the lowest-risk revenue lever.</a:t>
+            </a:r>
+          </a:p>
+        </p:txBody>
+      </p:sp>
+      <p:sp>
+        <p:nvSpPr>
+          <p:cNvPr id="14" name="Oval 13"/>
+          <p:cNvSpPr/>
+          <p:nvPr/>
+        </p:nvSpPr>
+        <p:spPr>
+          <a:xfrm>
+            <a:off x="640080" y="5394960"/>
+            <a:ext cx="868680" cy="868680"/>
+          </a:xfrm>
+          <a:prstGeom prst="ellipse">
+            <a:avLst/>
+          </a:prstGeom>
+          <a:solidFill>
+            <a:srgbClr val="F2A900"/>
+          </a:solidFill>
+          <a:ln>
+            <a:noFill/>
+          </a:ln>
+        </p:spPr>
+        <p:style>
+          <a:lnRef idx="1">
+            <a:schemeClr val="accent1"/>
+          </a:lnRef>
+          <a:fillRef idx="3">
+            <a:schemeClr val="accent1"/>
+          </a:fillRef>
+          <a:effectRef idx="2">
+            <a:schemeClr val="accent1"/>
+          </a:effectRef>
+          <a:fontRef idx="minor">
+            <a:schemeClr val="lt1"/>
+          </a:fontRef>
+        </p:style>
+        <p:txBody>
+          <a:bodyPr rtlCol="0" anchor="ctr" lIns="0" rIns="0" tIns="0" bIns="0"/>
+          <a:lstStyle/>
+          <a:p>
+            <a:pPr algn="ctr"/>
+            <a:r>
+              <a:rPr sz="2400" b="1">
+                <a:solidFill>
+                  <a:srgbClr val="012169"/>
+                </a:solidFill>
+                <a:latin typeface="Calibri"/>
+              </a:rPr>
+              <a:t>04</a:t>
+            </a:r>
+          </a:p>
+        </p:txBody>
+      </p:sp>
+      <p:sp>
+        <p:nvSpPr>
+          <p:cNvPr id="15" name="TextBox 14"/>
+          <p:cNvSpPr txBox="1"/>
+          <p:nvPr/>
+        </p:nvSpPr>
+        <p:spPr>
+          <a:xfrm>
+            <a:off x="1828800" y="5349240"/>
+            <a:ext cx="9814255" cy="411480"/>
+          </a:xfrm>
+          <a:prstGeom prst="rect">
+            <a:avLst/>
+          </a:prstGeom>
+          <a:noFill/>
+        </p:spPr>
+        <p:txBody>
+          <a:bodyPr wrap="square">
+            <a:spAutoFit/>
+          </a:bodyPr>
+          <a:lstStyle/>
+          <a:p>
+            <a:pPr algn="l"/>
+            <a:r>
+              <a:rPr sz="1600" b="1">
+                <a:solidFill>
+                  <a:srgbClr val="F2A900"/>
+                </a:solidFill>
+                <a:latin typeface="Calibri"/>
+              </a:rPr>
+              <a:t>Stabilize MDP discount rate with a formal aid policy</a:t>
+            </a:r>
+          </a:p>
+        </p:txBody>
+      </p:sp>
+      <p:sp>
+        <p:nvSpPr>
+          <p:cNvPr id="16" name="TextBox 15"/>
+          <p:cNvSpPr txBox="1"/>
+          <p:nvPr/>
+        </p:nvSpPr>
+        <p:spPr>
+          <a:xfrm>
+            <a:off x="1828800" y="5760720"/>
+            <a:ext cx="9814255" cy="777240"/>
+          </a:xfrm>
+          <a:prstGeom prst="rect">
+            <a:avLst/>
+          </a:prstGeom>
+          <a:noFill/>
+        </p:spPr>
+        <p:txBody>
+          <a:bodyPr wrap="square">
+            <a:spAutoFit/>
+          </a:bodyPr>
+          <a:lstStyle/>
+          <a:p>
+            <a:pPr algn="l"/>
+            <a:r>
+              <a:rPr sz="1100" b="0">
+                <a:solidFill>
+                  <a:srgbClr val="FFFFFF"/>
+                </a:solidFill>
+                <a:latin typeface="Calibri"/>
+              </a:rPr>
+              <a:t>MDP discounts at 55% career-wide and concentrates the give in Summer (~$22k gross → ~$2k net per Summer term). Year-to-year the rate drifts in a 55–60% band, which suggests the practice is implicit. Codify the rule (eligibility, award size, term distribution) so future cohorts are predictable and the rate can be tuned deliberately rather than by drift.</a:t>
+            </a:r>
+          </a:p>
+        </p:txBody>
+      </p:sp>
+      <p:sp>
+        <p:nvSpPr>
+          <p:cNvPr id="17" name="TextBox 16"/>
+          <p:cNvSpPr txBox="1"/>
+          <p:nvPr/>
+        </p:nvSpPr>
+        <p:spPr>
+          <a:xfrm>
+            <a:off x="11460175" y="6537960"/>
+            <a:ext cx="548640" cy="274320"/>
+          </a:xfrm>
+          <a:prstGeom prst="rect">
+            <a:avLst/>
+          </a:prstGeom>
+          <a:noFill/>
+        </p:spPr>
+        <p:txBody>
+          <a:bodyPr wrap="square">
+            <a:spAutoFit/>
+          </a:bodyPr>
+          <a:lstStyle/>
+          <a:p>
+            <a:pPr algn="r"/>
+            <a:r>
+              <a:rPr sz="1100" b="0">
+                <a:solidFill>
+                  <a:srgbClr val="F2A900"/>
+                </a:solidFill>
+                <a:latin typeface="Calibri"/>
+              </a:rPr>
+              <a:t>11</a:t>
+            </a:r>
+          </a:p>
+        </p:txBody>
+      </p:sp>
+    </p:spTree>
+  </p:cSld>
+  <p:clrMapOvr>
+    <a:masterClrMapping/>
+  </p:clrMapOvr>
+</p:sld>
+</file>
+
+<file path=ppt/slides/slide12.xml><?xml version="1.0" encoding="utf-8"?>
 <p:sld xmlns:a="http://schemas.openxmlformats.org/drawingml/2006/main" xmlns:p="http://schemas.openxmlformats.org/presentationml/2006/main" xmlns:r="http://schemas.openxmlformats.org/officeDocument/2006/relationships">
   <p:cSld>
     <p:spTree>

</xml_diff>

<commit_message>
Rework intl mix scatter: log x-axis, larger figure, left-panel slide
Chart updates: figsize 10x7 -> 14x9, symlog x-axis with explicit ticks
[0,1,2,5,10,20,40,80] to spread out the cluster of programs near 0%
intl share, MBID/Data Science labels split +/-1.5 pct so the (0%, 0%)
overlap is gone, bubbles ~60% larger so small-n programs remain
visible.

Deck slide 7 now uses the left navy panel layout (matching the per-
semester slides) instead of the full-width headline strip, and
build_left_panel_chart_slide reads the chart's true aspect via PIL
so the new 14:9 source PNG fits correctly alongside the 11:6 charts.

Co-Authored-By: Claude Opus 4.7 (1M context) <noreply@anthropic.com>
</commit_message>
<xml_diff>
--- a/deliverables/emory_grad_pricing_v2.pptx
+++ b/deliverables/emory_grad_pricing_v2.pptx
@@ -5517,8 +5517,8 @@
         </p:blipFill>
         <p:spPr>
           <a:xfrm>
-            <a:off x="4343400" y="1271930"/>
-            <a:ext cx="7573975" cy="4131259"/>
+            <a:off x="4343400" y="749653"/>
+            <a:ext cx="7573975" cy="5175813"/>
           </a:xfrm>
           <a:prstGeom prst="rect">
             <a:avLst/>
@@ -5750,8 +5750,8 @@
         </p:blipFill>
         <p:spPr>
           <a:xfrm>
-            <a:off x="4343400" y="1271930"/>
-            <a:ext cx="7573975" cy="4131259"/>
+            <a:off x="4343400" y="749653"/>
+            <a:ext cx="7573975" cy="5175813"/>
           </a:xfrm>
           <a:prstGeom prst="rect">
             <a:avLst/>
@@ -5983,8 +5983,8 @@
         </p:blipFill>
         <p:spPr>
           <a:xfrm>
-            <a:off x="4343400" y="1271930"/>
-            <a:ext cx="7573975" cy="4131259"/>
+            <a:off x="4343400" y="749653"/>
+            <a:ext cx="7573975" cy="5175813"/>
           </a:xfrm>
           <a:prstGeom prst="rect">
             <a:avLst/>
@@ -6053,7 +6053,7 @@
         <p:spPr>
           <a:xfrm>
             <a:off x="0" y="0"/>
-            <a:ext cx="12191695" cy="1188720"/>
+            <a:ext cx="4114800" cy="6858000"/>
           </a:xfrm>
           <a:prstGeom prst="rect">
             <a:avLst/>
@@ -6089,49 +6089,14 @@
       </p:sp>
       <p:sp>
         <p:nvSpPr>
-          <p:cNvPr id="3" name="TextBox 2"/>
-          <p:cNvSpPr txBox="1"/>
-          <p:nvPr/>
-        </p:nvSpPr>
-        <p:spPr>
-          <a:xfrm>
-            <a:off x="457200" y="228600"/>
-            <a:ext cx="11277295" cy="777240"/>
-          </a:xfrm>
-          <a:prstGeom prst="rect">
-            <a:avLst/>
-          </a:prstGeom>
-          <a:noFill/>
-        </p:spPr>
-        <p:txBody>
-          <a:bodyPr wrap="square">
-            <a:spAutoFit/>
-          </a:bodyPr>
-          <a:lstStyle/>
-          <a:p>
-            <a:pPr algn="l"/>
-            <a:r>
-              <a:rPr sz="2000" b="1">
-                <a:solidFill>
-                  <a:srgbClr val="FFFFFF"/>
-                </a:solidFill>
-                <a:latin typeface="Calibri"/>
-              </a:rPr>
-              <a:t>High international share doesn't come with lower aid — Computer Science is 86% international AND 49% discounted</a:t>
-            </a:r>
-          </a:p>
-        </p:txBody>
-      </p:sp>
-      <p:sp>
-        <p:nvSpPr>
-          <p:cNvPr id="4" name="Rectangle 3"/>
+          <p:cNvPr id="3" name="Rectangle 2"/>
           <p:cNvSpPr/>
           <p:nvPr/>
         </p:nvSpPr>
         <p:spPr>
           <a:xfrm>
-            <a:off x="0" y="1188720"/>
-            <a:ext cx="12191695" cy="54864"/>
+            <a:off x="4114800" y="0"/>
+            <a:ext cx="54864" cy="6858000"/>
           </a:xfrm>
           <a:prstGeom prst="rect">
             <a:avLst/>
@@ -6165,9 +6130,79 @@
           </a:p>
         </p:txBody>
       </p:sp>
+      <p:sp>
+        <p:nvSpPr>
+          <p:cNvPr id="4" name="TextBox 3"/>
+          <p:cNvSpPr txBox="1"/>
+          <p:nvPr/>
+        </p:nvSpPr>
+        <p:spPr>
+          <a:xfrm>
+            <a:off x="365760" y="914400"/>
+            <a:ext cx="3474720" cy="3657600"/>
+          </a:xfrm>
+          <a:prstGeom prst="rect">
+            <a:avLst/>
+          </a:prstGeom>
+          <a:noFill/>
+        </p:spPr>
+        <p:txBody>
+          <a:bodyPr wrap="square">
+            <a:spAutoFit/>
+          </a:bodyPr>
+          <a:lstStyle/>
+          <a:p>
+            <a:pPr algn="l"/>
+            <a:r>
+              <a:rPr sz="2000" b="1">
+                <a:solidFill>
+                  <a:srgbClr val="FFFFFF"/>
+                </a:solidFill>
+                <a:latin typeface="Calibri"/>
+              </a:rPr>
+              <a:t>High international share doesn't come with lower aid — CS is 86% international and 49% discounted</a:t>
+            </a:r>
+          </a:p>
+        </p:txBody>
+      </p:sp>
+      <p:sp>
+        <p:nvSpPr>
+          <p:cNvPr id="5" name="TextBox 4"/>
+          <p:cNvSpPr txBox="1"/>
+          <p:nvPr/>
+        </p:nvSpPr>
+        <p:spPr>
+          <a:xfrm>
+            <a:off x="365760" y="4937760"/>
+            <a:ext cx="3474720" cy="1463040"/>
+          </a:xfrm>
+          <a:prstGeom prst="rect">
+            <a:avLst/>
+          </a:prstGeom>
+          <a:noFill/>
+        </p:spPr>
+        <p:txBody>
+          <a:bodyPr wrap="square">
+            <a:spAutoFit/>
+          </a:bodyPr>
+          <a:lstStyle/>
+          <a:p>
+            <a:pPr algn="l"/>
+            <a:r>
+              <a:rPr sz="1300" b="0">
+                <a:solidFill>
+                  <a:srgbClr val="F2A900"/>
+                </a:solidFill>
+                <a:latin typeface="Calibri"/>
+              </a:rPr>
+              <a:t>Full population (n=487). Bubble size = enrollment; x-axis on log scale to spread the cluster of programs near 0%.</a:t>
+            </a:r>
+          </a:p>
+        </p:txBody>
+      </p:sp>
       <p:pic>
         <p:nvPicPr>
-          <p:cNvPr id="5" name="Picture 4" descr="03_intl_pct_vs_discount_rate.png"/>
+          <p:cNvPr id="6" name="Picture 5" descr="03_intl_pct_vs_discount_rate.png"/>
           <p:cNvPicPr>
             <a:picLocks noChangeAspect="1"/>
           </p:cNvPicPr>
@@ -6181,8 +6216,8 @@
         </p:blipFill>
         <p:spPr>
           <a:xfrm>
-            <a:off x="457200" y="1463040"/>
-            <a:ext cx="11277295" cy="5029200"/>
+            <a:off x="4343400" y="1059629"/>
+            <a:ext cx="7573975" cy="4555860"/>
           </a:xfrm>
           <a:prstGeom prst="rect">
             <a:avLst/>
@@ -6191,7 +6226,7 @@
       </p:pic>
       <p:sp>
         <p:nvSpPr>
-          <p:cNvPr id="6" name="TextBox 5"/>
+          <p:cNvPr id="7" name="TextBox 6"/>
           <p:cNvSpPr txBox="1"/>
           <p:nvPr/>
         </p:nvSpPr>

</xml_diff>